<commit_message>
semester 8 complete notes
</commit_message>
<xml_diff>
--- a/software testing/notes/Week5 State Transition Testing Technique.pptx
+++ b/software testing/notes/Week5 State Transition Testing Technique.pptx
@@ -1,27 +1,27 @@
 
 <file path=ppt/presentation.xml><?xml version="1.0" encoding="utf-8"?>
-<p:presentation xmlns:a="http://schemas.openxmlformats.org/drawingml/2006/main" xmlns:r="http://schemas.openxmlformats.org/officeDocument/2006/relationships" xmlns:p="http://schemas.openxmlformats.org/presentationml/2006/main" saveSubsetFonts="1">
+<p:presentation xmlns:a="http://schemas.openxmlformats.org/drawingml/2006/main" xmlns:r="http://schemas.openxmlformats.org/officeDocument/2006/relationships" xmlns:p="http://schemas.openxmlformats.org/presentationml/2006/main">
   <p:sldMasterIdLst>
-    <p:sldMasterId id="2147483660" r:id="rId1"/>
+    <p:sldMasterId id="2147483648" r:id="rId1"/>
   </p:sldMasterIdLst>
   <p:sldIdLst>
-    <p:sldId id="256" r:id="rId2"/>
-    <p:sldId id="259" r:id="rId3"/>
-    <p:sldId id="257" r:id="rId4"/>
-    <p:sldId id="258" r:id="rId5"/>
-    <p:sldId id="273" r:id="rId6"/>
-    <p:sldId id="260" r:id="rId7"/>
-    <p:sldId id="261" r:id="rId8"/>
-    <p:sldId id="269" r:id="rId9"/>
-    <p:sldId id="271" r:id="rId10"/>
-    <p:sldId id="262" r:id="rId11"/>
-    <p:sldId id="263" r:id="rId12"/>
-    <p:sldId id="272" r:id="rId13"/>
-    <p:sldId id="264" r:id="rId14"/>
-    <p:sldId id="266" r:id="rId15"/>
-    <p:sldId id="267" r:id="rId16"/>
-    <p:sldId id="268" r:id="rId17"/>
-    <p:sldId id="270" r:id="rId18"/>
+    <p:sldId id="256" r:id="rId3"/>
+    <p:sldId id="259" r:id="rId4"/>
+    <p:sldId id="257" r:id="rId5"/>
+    <p:sldId id="258" r:id="rId6"/>
+    <p:sldId id="273" r:id="rId7"/>
+    <p:sldId id="260" r:id="rId8"/>
+    <p:sldId id="261" r:id="rId9"/>
+    <p:sldId id="269" r:id="rId10"/>
+    <p:sldId id="271" r:id="rId11"/>
+    <p:sldId id="262" r:id="rId12"/>
+    <p:sldId id="263" r:id="rId13"/>
+    <p:sldId id="272" r:id="rId14"/>
+    <p:sldId id="264" r:id="rId15"/>
+    <p:sldId id="266" r:id="rId16"/>
+    <p:sldId id="267" r:id="rId17"/>
+    <p:sldId id="268" r:id="rId18"/>
+    <p:sldId id="270" r:id="rId19"/>
   </p:sldIdLst>
   <p:sldSz cx="9144000" cy="6858000" type="screen4x3"/>
   <p:notesSz cx="6858000" cy="9144000"/>
@@ -123,12 +123,12 @@
   <p:extLst>
     <p:ext uri="{EFAFB233-063F-42B5-8137-9DF3F51BA10A}">
       <p15:sldGuideLst xmlns:p15="http://schemas.microsoft.com/office/powerpoint/2012/main">
-        <p15:guide id="1" orient="horz" pos="2160">
+        <p15:guide id="1" orient="horz" pos="2160" userDrawn="1">
           <p15:clr>
             <a:srgbClr val="A4A3A4"/>
           </p15:clr>
         </p15:guide>
-        <p15:guide id="2" pos="2880">
+        <p15:guide id="2" pos="2880" userDrawn="1">
           <p15:clr>
             <a:srgbClr val="A4A3A4"/>
           </p15:clr>
@@ -140,7 +140,7 @@
 </file>
 
 <file path=ppt/slideLayouts/slideLayout1.xml><?xml version="1.0" encoding="utf-8"?>
-<p:sldLayout xmlns:a="http://schemas.openxmlformats.org/drawingml/2006/main" xmlns:r="http://schemas.openxmlformats.org/officeDocument/2006/relationships" xmlns:p="http://schemas.openxmlformats.org/presentationml/2006/main" showMasterSp="0" type="title" preserve="1">
+<p:sldLayout xmlns:a="http://schemas.openxmlformats.org/drawingml/2006/main" xmlns:r="http://schemas.openxmlformats.org/officeDocument/2006/relationships" xmlns:p="http://schemas.openxmlformats.org/presentationml/2006/main" type="title" preserve="1" showMasterSp="0">
   <p:cSld name="Title Slide">
     <p:spTree>
       <p:nvGrpSpPr>
@@ -6772,8 +6772,6 @@
           <a:p>
             <a:fld id="{228800AE-E086-4866-AA97-D98DE7A11C28}" type="datetimeFigureOut">
               <a:rPr lang="en-US" smtClean="0"/>
-              <a:pPr/>
-              <a:t>2/18/2026</a:t>
             </a:fld>
             <a:endParaRPr lang="en-US"/>
           </a:p>
@@ -6815,8 +6813,6 @@
           <a:p>
             <a:fld id="{71292EF8-641F-46ED-8F12-FD5277AE86D7}" type="slidenum">
               <a:rPr lang="en-US" smtClean="0"/>
-              <a:pPr/>
-              <a:t>‹#›</a:t>
             </a:fld>
             <a:endParaRPr lang="en-US"/>
           </a:p>
@@ -6860,11 +6856,6 @@
         </p:style>
       </p:cxnSp>
     </p:spTree>
-    <p:extLst>
-      <p:ext uri="{BB962C8B-B14F-4D97-AF65-F5344CB8AC3E}">
-        <p14:creationId xmlns:p14="http://schemas.microsoft.com/office/powerpoint/2010/main" val="1396212382"/>
-      </p:ext>
-    </p:extLst>
   </p:cSld>
   <p:clrMapOvr>
     <a:masterClrMapping/>
@@ -6932,6 +6923,7 @@
               <a:rPr lang="en-US" smtClean="0"/>
               <a:t>Click to edit Master text styles</a:t>
             </a:r>
+            <a:endParaRPr lang="en-US" smtClean="0"/>
           </a:p>
           <a:p>
             <a:pPr lvl="1"/>
@@ -6939,6 +6931,7 @@
               <a:rPr lang="en-US" smtClean="0"/>
               <a:t>Second level</a:t>
             </a:r>
+            <a:endParaRPr lang="en-US" smtClean="0"/>
           </a:p>
           <a:p>
             <a:pPr lvl="2"/>
@@ -6946,6 +6939,7 @@
               <a:rPr lang="en-US" smtClean="0"/>
               <a:t>Third level</a:t>
             </a:r>
+            <a:endParaRPr lang="en-US" smtClean="0"/>
           </a:p>
           <a:p>
             <a:pPr lvl="3"/>
@@ -6953,6 +6947,7 @@
               <a:rPr lang="en-US" smtClean="0"/>
               <a:t>Fourth level</a:t>
             </a:r>
+            <a:endParaRPr lang="en-US" smtClean="0"/>
           </a:p>
           <a:p>
             <a:pPr lvl="4"/>
@@ -6981,8 +6976,6 @@
           <a:p>
             <a:fld id="{228800AE-E086-4866-AA97-D98DE7A11C28}" type="datetimeFigureOut">
               <a:rPr lang="en-US" smtClean="0"/>
-              <a:pPr/>
-              <a:t>2/18/2026</a:t>
             </a:fld>
             <a:endParaRPr lang="en-US"/>
           </a:p>
@@ -7024,19 +7017,12 @@
           <a:p>
             <a:fld id="{71292EF8-641F-46ED-8F12-FD5277AE86D7}" type="slidenum">
               <a:rPr lang="en-US" smtClean="0"/>
-              <a:pPr/>
-              <a:t>‹#›</a:t>
             </a:fld>
             <a:endParaRPr lang="en-US"/>
           </a:p>
         </p:txBody>
       </p:sp>
     </p:spTree>
-    <p:extLst>
-      <p:ext uri="{BB962C8B-B14F-4D97-AF65-F5344CB8AC3E}">
-        <p14:creationId xmlns:p14="http://schemas.microsoft.com/office/powerpoint/2010/main" val="1346309165"/>
-      </p:ext>
-    </p:extLst>
   </p:cSld>
   <p:clrMapOvr>
     <a:masterClrMapping/>
@@ -7045,7 +7031,7 @@
 </file>
 
 <file path=ppt/slideLayouts/slideLayout11.xml><?xml version="1.0" encoding="utf-8"?>
-<p:sldLayout xmlns:a="http://schemas.openxmlformats.org/drawingml/2006/main" xmlns:r="http://schemas.openxmlformats.org/officeDocument/2006/relationships" xmlns:p="http://schemas.openxmlformats.org/presentationml/2006/main" showMasterSp="0" type="vertTitleAndTx" preserve="1">
+<p:sldLayout xmlns:a="http://schemas.openxmlformats.org/drawingml/2006/main" xmlns:r="http://schemas.openxmlformats.org/officeDocument/2006/relationships" xmlns:p="http://schemas.openxmlformats.org/presentationml/2006/main" type="vertTitleAndTx" preserve="1" showMasterSp="0">
   <p:cSld name="Vertical Title and Text">
     <p:spTree>
       <p:nvGrpSpPr>
@@ -7114,6 +7100,7 @@
               <a:rPr lang="en-US" smtClean="0"/>
               <a:t>Click to edit Master text styles</a:t>
             </a:r>
+            <a:endParaRPr lang="en-US" smtClean="0"/>
           </a:p>
           <a:p>
             <a:pPr lvl="1"/>
@@ -7121,6 +7108,7 @@
               <a:rPr lang="en-US" smtClean="0"/>
               <a:t>Second level</a:t>
             </a:r>
+            <a:endParaRPr lang="en-US" smtClean="0"/>
           </a:p>
           <a:p>
             <a:pPr lvl="2"/>
@@ -7128,6 +7116,7 @@
               <a:rPr lang="en-US" smtClean="0"/>
               <a:t>Third level</a:t>
             </a:r>
+            <a:endParaRPr lang="en-US" smtClean="0"/>
           </a:p>
           <a:p>
             <a:pPr lvl="3"/>
@@ -7135,6 +7124,7 @@
               <a:rPr lang="en-US" smtClean="0"/>
               <a:t>Fourth level</a:t>
             </a:r>
+            <a:endParaRPr lang="en-US" smtClean="0"/>
           </a:p>
           <a:p>
             <a:pPr lvl="4"/>
@@ -7163,8 +7153,6 @@
           <a:p>
             <a:fld id="{228800AE-E086-4866-AA97-D98DE7A11C28}" type="datetimeFigureOut">
               <a:rPr lang="en-US" smtClean="0"/>
-              <a:pPr/>
-              <a:t>2/18/2026</a:t>
             </a:fld>
             <a:endParaRPr lang="en-US"/>
           </a:p>
@@ -7206,8 +7194,6 @@
           <a:p>
             <a:fld id="{71292EF8-641F-46ED-8F12-FD5277AE86D7}" type="slidenum">
               <a:rPr lang="en-US" smtClean="0"/>
-              <a:pPr/>
-              <a:t>‹#›</a:t>
             </a:fld>
             <a:endParaRPr lang="en-US"/>
           </a:p>
@@ -7249,11 +7235,6 @@
         </p:style>
       </p:cxnSp>
     </p:spTree>
-    <p:extLst>
-      <p:ext uri="{BB962C8B-B14F-4D97-AF65-F5344CB8AC3E}">
-        <p14:creationId xmlns:p14="http://schemas.microsoft.com/office/powerpoint/2010/main" val="3935561323"/>
-      </p:ext>
-    </p:extLst>
   </p:cSld>
   <p:clrMapOvr>
     <a:masterClrMapping/>
@@ -7321,6 +7302,7 @@
               <a:rPr lang="en-US" smtClean="0"/>
               <a:t>Click to edit Master text styles</a:t>
             </a:r>
+            <a:endParaRPr lang="en-US" smtClean="0"/>
           </a:p>
           <a:p>
             <a:pPr lvl="1"/>
@@ -7328,6 +7310,7 @@
               <a:rPr lang="en-US" smtClean="0"/>
               <a:t>Second level</a:t>
             </a:r>
+            <a:endParaRPr lang="en-US" smtClean="0"/>
           </a:p>
           <a:p>
             <a:pPr lvl="2"/>
@@ -7335,6 +7318,7 @@
               <a:rPr lang="en-US" smtClean="0"/>
               <a:t>Third level</a:t>
             </a:r>
+            <a:endParaRPr lang="en-US" smtClean="0"/>
           </a:p>
           <a:p>
             <a:pPr lvl="3"/>
@@ -7342,6 +7326,7 @@
               <a:rPr lang="en-US" smtClean="0"/>
               <a:t>Fourth level</a:t>
             </a:r>
+            <a:endParaRPr lang="en-US" smtClean="0"/>
           </a:p>
           <a:p>
             <a:pPr lvl="4"/>
@@ -7370,8 +7355,6 @@
           <a:p>
             <a:fld id="{228800AE-E086-4866-AA97-D98DE7A11C28}" type="datetimeFigureOut">
               <a:rPr lang="en-US" smtClean="0"/>
-              <a:pPr/>
-              <a:t>2/18/2026</a:t>
             </a:fld>
             <a:endParaRPr lang="en-US"/>
           </a:p>
@@ -7413,19 +7396,12 @@
           <a:p>
             <a:fld id="{71292EF8-641F-46ED-8F12-FD5277AE86D7}" type="slidenum">
               <a:rPr lang="en-US" smtClean="0"/>
-              <a:pPr/>
-              <a:t>‹#›</a:t>
             </a:fld>
             <a:endParaRPr lang="en-US"/>
           </a:p>
         </p:txBody>
       </p:sp>
     </p:spTree>
-    <p:extLst>
-      <p:ext uri="{BB962C8B-B14F-4D97-AF65-F5344CB8AC3E}">
-        <p14:creationId xmlns:p14="http://schemas.microsoft.com/office/powerpoint/2010/main" val="3986446050"/>
-      </p:ext>
-    </p:extLst>
   </p:cSld>
   <p:clrMapOvr>
     <a:masterClrMapping/>
@@ -7434,7 +7410,7 @@
 </file>
 
 <file path=ppt/slideLayouts/slideLayout3.xml><?xml version="1.0" encoding="utf-8"?>
-<p:sldLayout xmlns:a="http://schemas.openxmlformats.org/drawingml/2006/main" xmlns:r="http://schemas.openxmlformats.org/officeDocument/2006/relationships" xmlns:p="http://schemas.openxmlformats.org/presentationml/2006/main" showMasterSp="0" type="secHead" preserve="1">
+<p:sldLayout xmlns:a="http://schemas.openxmlformats.org/drawingml/2006/main" xmlns:r="http://schemas.openxmlformats.org/officeDocument/2006/relationships" xmlns:p="http://schemas.openxmlformats.org/presentationml/2006/main" type="secHead" preserve="1" showMasterSp="0">
   <p:cSld name="Section Header">
     <p:spTree>
       <p:nvGrpSpPr>
@@ -14090,6 +14066,7 @@
               <a:rPr lang="en-US" smtClean="0"/>
               <a:t>Click to edit Master text styles</a:t>
             </a:r>
+            <a:endParaRPr lang="en-US" smtClean="0"/>
           </a:p>
         </p:txBody>
       </p:sp>
@@ -14110,8 +14087,6 @@
           <a:p>
             <a:fld id="{228800AE-E086-4866-AA97-D98DE7A11C28}" type="datetimeFigureOut">
               <a:rPr lang="en-US" smtClean="0"/>
-              <a:pPr/>
-              <a:t>2/18/2026</a:t>
             </a:fld>
             <a:endParaRPr lang="en-US"/>
           </a:p>
@@ -14153,8 +14128,6 @@
           <a:p>
             <a:fld id="{71292EF8-641F-46ED-8F12-FD5277AE86D7}" type="slidenum">
               <a:rPr lang="en-US" smtClean="0"/>
-              <a:pPr/>
-              <a:t>‹#›</a:t>
             </a:fld>
             <a:endParaRPr lang="en-US"/>
           </a:p>
@@ -14198,11 +14171,6 @@
         </p:style>
       </p:cxnSp>
     </p:spTree>
-    <p:extLst>
-      <p:ext uri="{BB962C8B-B14F-4D97-AF65-F5344CB8AC3E}">
-        <p14:creationId xmlns:p14="http://schemas.microsoft.com/office/powerpoint/2010/main" val="656360820"/>
-      </p:ext>
-    </p:extLst>
   </p:cSld>
   <p:clrMapOvr>
     <a:masterClrMapping/>
@@ -14280,6 +14248,7 @@
               <a:rPr lang="en-US" smtClean="0"/>
               <a:t>Click to edit Master text styles</a:t>
             </a:r>
+            <a:endParaRPr lang="en-US" smtClean="0"/>
           </a:p>
           <a:p>
             <a:pPr lvl="1"/>
@@ -14287,6 +14256,7 @@
               <a:rPr lang="en-US" smtClean="0"/>
               <a:t>Second level</a:t>
             </a:r>
+            <a:endParaRPr lang="en-US" smtClean="0"/>
           </a:p>
           <a:p>
             <a:pPr lvl="2"/>
@@ -14294,6 +14264,7 @@
               <a:rPr lang="en-US" smtClean="0"/>
               <a:t>Third level</a:t>
             </a:r>
+            <a:endParaRPr lang="en-US" smtClean="0"/>
           </a:p>
           <a:p>
             <a:pPr lvl="3"/>
@@ -14301,6 +14272,7 @@
               <a:rPr lang="en-US" smtClean="0"/>
               <a:t>Fourth level</a:t>
             </a:r>
+            <a:endParaRPr lang="en-US" smtClean="0"/>
           </a:p>
           <a:p>
             <a:pPr lvl="4"/>
@@ -14337,6 +14309,7 @@
               <a:rPr lang="en-US" smtClean="0"/>
               <a:t>Click to edit Master text styles</a:t>
             </a:r>
+            <a:endParaRPr lang="en-US" smtClean="0"/>
           </a:p>
           <a:p>
             <a:pPr lvl="1"/>
@@ -14344,6 +14317,7 @@
               <a:rPr lang="en-US" smtClean="0"/>
               <a:t>Second level</a:t>
             </a:r>
+            <a:endParaRPr lang="en-US" smtClean="0"/>
           </a:p>
           <a:p>
             <a:pPr lvl="2"/>
@@ -14351,6 +14325,7 @@
               <a:rPr lang="en-US" smtClean="0"/>
               <a:t>Third level</a:t>
             </a:r>
+            <a:endParaRPr lang="en-US" smtClean="0"/>
           </a:p>
           <a:p>
             <a:pPr lvl="3"/>
@@ -14358,6 +14333,7 @@
               <a:rPr lang="en-US" smtClean="0"/>
               <a:t>Fourth level</a:t>
             </a:r>
+            <a:endParaRPr lang="en-US" smtClean="0"/>
           </a:p>
           <a:p>
             <a:pPr lvl="4"/>
@@ -14386,8 +14362,6 @@
           <a:p>
             <a:fld id="{228800AE-E086-4866-AA97-D98DE7A11C28}" type="datetimeFigureOut">
               <a:rPr lang="en-US" smtClean="0"/>
-              <a:pPr/>
-              <a:t>2/18/2026</a:t>
             </a:fld>
             <a:endParaRPr lang="en-US"/>
           </a:p>
@@ -14429,19 +14403,12 @@
           <a:p>
             <a:fld id="{71292EF8-641F-46ED-8F12-FD5277AE86D7}" type="slidenum">
               <a:rPr lang="en-US" smtClean="0"/>
-              <a:pPr/>
-              <a:t>‹#›</a:t>
             </a:fld>
             <a:endParaRPr lang="en-US"/>
           </a:p>
         </p:txBody>
       </p:sp>
     </p:spTree>
-    <p:extLst>
-      <p:ext uri="{BB962C8B-B14F-4D97-AF65-F5344CB8AC3E}">
-        <p14:creationId xmlns:p14="http://schemas.microsoft.com/office/powerpoint/2010/main" val="3367466962"/>
-      </p:ext>
-    </p:extLst>
   </p:cSld>
   <p:clrMapOvr>
     <a:masterClrMapping/>
@@ -14569,6 +14536,7 @@
               <a:rPr lang="en-US" smtClean="0"/>
               <a:t>Click to edit Master text styles</a:t>
             </a:r>
+            <a:endParaRPr lang="en-US" smtClean="0"/>
           </a:p>
         </p:txBody>
       </p:sp>
@@ -14597,6 +14565,7 @@
               <a:rPr lang="en-US" smtClean="0"/>
               <a:t>Click to edit Master text styles</a:t>
             </a:r>
+            <a:endParaRPr lang="en-US" smtClean="0"/>
           </a:p>
           <a:p>
             <a:pPr lvl="1"/>
@@ -14604,6 +14573,7 @@
               <a:rPr lang="en-US" smtClean="0"/>
               <a:t>Second level</a:t>
             </a:r>
+            <a:endParaRPr lang="en-US" smtClean="0"/>
           </a:p>
           <a:p>
             <a:pPr lvl="2"/>
@@ -14611,6 +14581,7 @@
               <a:rPr lang="en-US" smtClean="0"/>
               <a:t>Third level</a:t>
             </a:r>
+            <a:endParaRPr lang="en-US" smtClean="0"/>
           </a:p>
           <a:p>
             <a:pPr lvl="3"/>
@@ -14618,6 +14589,7 @@
               <a:rPr lang="en-US" smtClean="0"/>
               <a:t>Fourth level</a:t>
             </a:r>
+            <a:endParaRPr lang="en-US" smtClean="0"/>
           </a:p>
           <a:p>
             <a:pPr lvl="4"/>
@@ -14714,6 +14686,7 @@
               <a:rPr lang="en-US" smtClean="0"/>
               <a:t>Click to edit Master text styles</a:t>
             </a:r>
+            <a:endParaRPr lang="en-US" smtClean="0"/>
           </a:p>
         </p:txBody>
       </p:sp>
@@ -14742,6 +14715,7 @@
               <a:rPr lang="en-US" smtClean="0"/>
               <a:t>Click to edit Master text styles</a:t>
             </a:r>
+            <a:endParaRPr lang="en-US" smtClean="0"/>
           </a:p>
           <a:p>
             <a:pPr lvl="1"/>
@@ -14749,6 +14723,7 @@
               <a:rPr lang="en-US" smtClean="0"/>
               <a:t>Second level</a:t>
             </a:r>
+            <a:endParaRPr lang="en-US" smtClean="0"/>
           </a:p>
           <a:p>
             <a:pPr lvl="2"/>
@@ -14756,6 +14731,7 @@
               <a:rPr lang="en-US" smtClean="0"/>
               <a:t>Third level</a:t>
             </a:r>
+            <a:endParaRPr lang="en-US" smtClean="0"/>
           </a:p>
           <a:p>
             <a:pPr lvl="3"/>
@@ -14763,6 +14739,7 @@
               <a:rPr lang="en-US" smtClean="0"/>
               <a:t>Fourth level</a:t>
             </a:r>
+            <a:endParaRPr lang="en-US" smtClean="0"/>
           </a:p>
           <a:p>
             <a:pPr lvl="4"/>
@@ -14791,8 +14768,6 @@
           <a:p>
             <a:fld id="{228800AE-E086-4866-AA97-D98DE7A11C28}" type="datetimeFigureOut">
               <a:rPr lang="en-US" smtClean="0"/>
-              <a:pPr/>
-              <a:t>2/18/2026</a:t>
             </a:fld>
             <a:endParaRPr lang="en-US"/>
           </a:p>
@@ -14834,19 +14809,12 @@
           <a:p>
             <a:fld id="{71292EF8-641F-46ED-8F12-FD5277AE86D7}" type="slidenum">
               <a:rPr lang="en-US" smtClean="0"/>
-              <a:pPr/>
-              <a:t>‹#›</a:t>
             </a:fld>
             <a:endParaRPr lang="en-US"/>
           </a:p>
         </p:txBody>
       </p:sp>
     </p:spTree>
-    <p:extLst>
-      <p:ext uri="{BB962C8B-B14F-4D97-AF65-F5344CB8AC3E}">
-        <p14:creationId xmlns:p14="http://schemas.microsoft.com/office/powerpoint/2010/main" val="453677207"/>
-      </p:ext>
-    </p:extLst>
   </p:cSld>
   <p:clrMapOvr>
     <a:masterClrMapping/>
@@ -14911,8 +14879,6 @@
           <a:p>
             <a:fld id="{228800AE-E086-4866-AA97-D98DE7A11C28}" type="datetimeFigureOut">
               <a:rPr lang="en-US" smtClean="0"/>
-              <a:pPr/>
-              <a:t>2/18/2026</a:t>
             </a:fld>
             <a:endParaRPr lang="en-US"/>
           </a:p>
@@ -14954,19 +14920,12 @@
           <a:p>
             <a:fld id="{71292EF8-641F-46ED-8F12-FD5277AE86D7}" type="slidenum">
               <a:rPr lang="en-US" smtClean="0"/>
-              <a:pPr/>
-              <a:t>‹#›</a:t>
             </a:fld>
             <a:endParaRPr lang="en-US"/>
           </a:p>
         </p:txBody>
       </p:sp>
     </p:spTree>
-    <p:extLst>
-      <p:ext uri="{BB962C8B-B14F-4D97-AF65-F5344CB8AC3E}">
-        <p14:creationId xmlns:p14="http://schemas.microsoft.com/office/powerpoint/2010/main" val="2943981171"/>
-      </p:ext>
-    </p:extLst>
   </p:cSld>
   <p:clrMapOvr>
     <a:masterClrMapping/>
@@ -14975,7 +14934,7 @@
 </file>
 
 <file path=ppt/slideLayouts/slideLayout7.xml><?xml version="1.0" encoding="utf-8"?>
-<p:sldLayout xmlns:a="http://schemas.openxmlformats.org/drawingml/2006/main" xmlns:r="http://schemas.openxmlformats.org/officeDocument/2006/relationships" xmlns:p="http://schemas.openxmlformats.org/presentationml/2006/main" showMasterSp="0" type="blank" preserve="1">
+<p:sldLayout xmlns:a="http://schemas.openxmlformats.org/drawingml/2006/main" xmlns:r="http://schemas.openxmlformats.org/officeDocument/2006/relationships" xmlns:p="http://schemas.openxmlformats.org/presentationml/2006/main" type="blank" preserve="1" showMasterSp="0">
   <p:cSld name="Blank">
     <p:spTree>
       <p:nvGrpSpPr>
@@ -15008,8 +14967,6 @@
           <a:p>
             <a:fld id="{228800AE-E086-4866-AA97-D98DE7A11C28}" type="datetimeFigureOut">
               <a:rPr lang="en-US" smtClean="0"/>
-              <a:pPr/>
-              <a:t>2/18/2026</a:t>
             </a:fld>
             <a:endParaRPr lang="en-US"/>
           </a:p>
@@ -15051,19 +15008,12 @@
           <a:p>
             <a:fld id="{71292EF8-641F-46ED-8F12-FD5277AE86D7}" type="slidenum">
               <a:rPr lang="en-US" smtClean="0"/>
-              <a:pPr/>
-              <a:t>‹#›</a:t>
             </a:fld>
             <a:endParaRPr lang="en-US"/>
           </a:p>
         </p:txBody>
       </p:sp>
     </p:spTree>
-    <p:extLst>
-      <p:ext uri="{BB962C8B-B14F-4D97-AF65-F5344CB8AC3E}">
-        <p14:creationId xmlns:p14="http://schemas.microsoft.com/office/powerpoint/2010/main" val="2727514325"/>
-      </p:ext>
-    </p:extLst>
   </p:cSld>
   <p:clrMapOvr>
     <a:masterClrMapping/>
@@ -15180,6 +15130,7 @@
               <a:rPr lang="en-US" smtClean="0"/>
               <a:t>Click to edit Master text styles</a:t>
             </a:r>
+            <a:endParaRPr lang="en-US" smtClean="0"/>
           </a:p>
           <a:p>
             <a:pPr lvl="1"/>
@@ -15187,6 +15138,7 @@
               <a:rPr lang="en-US" smtClean="0"/>
               <a:t>Second level</a:t>
             </a:r>
+            <a:endParaRPr lang="en-US" smtClean="0"/>
           </a:p>
           <a:p>
             <a:pPr lvl="2"/>
@@ -15194,6 +15146,7 @@
               <a:rPr lang="en-US" smtClean="0"/>
               <a:t>Third level</a:t>
             </a:r>
+            <a:endParaRPr lang="en-US" smtClean="0"/>
           </a:p>
           <a:p>
             <a:pPr lvl="3"/>
@@ -15201,6 +15154,7 @@
               <a:rPr lang="en-US" smtClean="0"/>
               <a:t>Fourth level</a:t>
             </a:r>
+            <a:endParaRPr lang="en-US" smtClean="0"/>
           </a:p>
           <a:p>
             <a:pPr lvl="4"/>
@@ -15282,6 +15236,7 @@
               <a:rPr lang="en-US" smtClean="0"/>
               <a:t>Click to edit Master text styles</a:t>
             </a:r>
+            <a:endParaRPr lang="en-US" smtClean="0"/>
           </a:p>
         </p:txBody>
       </p:sp>
@@ -15302,8 +15257,6 @@
           <a:p>
             <a:fld id="{228800AE-E086-4866-AA97-D98DE7A11C28}" type="datetimeFigureOut">
               <a:rPr lang="en-US" smtClean="0"/>
-              <a:pPr/>
-              <a:t>2/18/2026</a:t>
             </a:fld>
             <a:endParaRPr lang="en-US"/>
           </a:p>
@@ -15345,19 +15298,12 @@
           <a:p>
             <a:fld id="{71292EF8-641F-46ED-8F12-FD5277AE86D7}" type="slidenum">
               <a:rPr lang="en-US" smtClean="0"/>
-              <a:pPr/>
-              <a:t>‹#›</a:t>
             </a:fld>
             <a:endParaRPr lang="en-US"/>
           </a:p>
         </p:txBody>
       </p:sp>
     </p:spTree>
-    <p:extLst>
-      <p:ext uri="{BB962C8B-B14F-4D97-AF65-F5344CB8AC3E}">
-        <p14:creationId xmlns:p14="http://schemas.microsoft.com/office/powerpoint/2010/main" val="1344710704"/>
-      </p:ext>
-    </p:extLst>
   </p:cSld>
   <p:clrMapOvr>
     <a:masterClrMapping/>
@@ -15366,7 +15312,7 @@
 </file>
 
 <file path=ppt/slideLayouts/slideLayout9.xml><?xml version="1.0" encoding="utf-8"?>
-<p:sldLayout xmlns:a="http://schemas.openxmlformats.org/drawingml/2006/main" xmlns:r="http://schemas.openxmlformats.org/officeDocument/2006/relationships" xmlns:p="http://schemas.openxmlformats.org/presentationml/2006/main" showMasterSp="0" type="picTx" preserve="1">
+<p:sldLayout xmlns:a="http://schemas.openxmlformats.org/drawingml/2006/main" xmlns:r="http://schemas.openxmlformats.org/officeDocument/2006/relationships" xmlns:p="http://schemas.openxmlformats.org/presentationml/2006/main" type="picTx" preserve="1" showMasterSp="0">
   <p:cSld name="Picture with Caption">
     <p:spTree>
       <p:nvGrpSpPr>
@@ -15564,6 +15510,7 @@
               <a:rPr lang="en-US" smtClean="0"/>
               <a:t>Click to edit Master text styles</a:t>
             </a:r>
+            <a:endParaRPr lang="en-US" smtClean="0"/>
           </a:p>
         </p:txBody>
       </p:sp>
@@ -15584,8 +15531,6 @@
           <a:p>
             <a:fld id="{228800AE-E086-4866-AA97-D98DE7A11C28}" type="datetimeFigureOut">
               <a:rPr lang="en-US" smtClean="0"/>
-              <a:pPr/>
-              <a:t>2/18/2026</a:t>
             </a:fld>
             <a:endParaRPr lang="en-US"/>
           </a:p>
@@ -15627,8 +15572,6 @@
           <a:p>
             <a:fld id="{71292EF8-641F-46ED-8F12-FD5277AE86D7}" type="slidenum">
               <a:rPr lang="en-US" smtClean="0"/>
-              <a:pPr/>
-              <a:t>‹#›</a:t>
             </a:fld>
             <a:endParaRPr lang="en-US"/>
           </a:p>
@@ -15670,11 +15613,6 @@
         </p:style>
       </p:cxnSp>
     </p:spTree>
-    <p:extLst>
-      <p:ext uri="{BB962C8B-B14F-4D97-AF65-F5344CB8AC3E}">
-        <p14:creationId xmlns:p14="http://schemas.microsoft.com/office/powerpoint/2010/main" val="1257454836"/>
-      </p:ext>
-    </p:extLst>
   </p:cSld>
   <p:clrMapOvr>
     <a:masterClrMapping/>
@@ -15767,6 +15705,7 @@
               <a:rPr lang="en-US" smtClean="0"/>
               <a:t>Click to edit Master text styles</a:t>
             </a:r>
+            <a:endParaRPr lang="en-US" smtClean="0"/>
           </a:p>
           <a:p>
             <a:pPr lvl="1"/>
@@ -15774,6 +15713,7 @@
               <a:rPr lang="en-US" smtClean="0"/>
               <a:t>Second level</a:t>
             </a:r>
+            <a:endParaRPr lang="en-US" smtClean="0"/>
           </a:p>
           <a:p>
             <a:pPr lvl="2"/>
@@ -15781,6 +15721,7 @@
               <a:rPr lang="en-US" smtClean="0"/>
               <a:t>Third level</a:t>
             </a:r>
+            <a:endParaRPr lang="en-US" smtClean="0"/>
           </a:p>
           <a:p>
             <a:pPr lvl="3"/>
@@ -15788,6 +15729,7 @@
               <a:rPr lang="en-US" smtClean="0"/>
               <a:t>Fourth level</a:t>
             </a:r>
+            <a:endParaRPr lang="en-US" smtClean="0"/>
           </a:p>
           <a:p>
             <a:pPr lvl="4"/>
@@ -15836,8 +15778,6 @@
           <a:p>
             <a:fld id="{228800AE-E086-4866-AA97-D98DE7A11C28}" type="datetimeFigureOut">
               <a:rPr lang="en-US" smtClean="0"/>
-              <a:pPr/>
-              <a:t>2/18/2026</a:t>
             </a:fld>
             <a:endParaRPr lang="en-US"/>
           </a:p>
@@ -15919,8 +15859,6 @@
           <a:p>
             <a:fld id="{71292EF8-641F-46ED-8F12-FD5277AE86D7}" type="slidenum">
               <a:rPr lang="en-US" smtClean="0"/>
-              <a:pPr/>
-              <a:t>‹#›</a:t>
             </a:fld>
             <a:endParaRPr lang="en-US"/>
           </a:p>
@@ -15962,25 +15900,20 @@
         </p:style>
       </p:cxnSp>
     </p:spTree>
-    <p:extLst>
-      <p:ext uri="{BB962C8B-B14F-4D97-AF65-F5344CB8AC3E}">
-        <p14:creationId xmlns:p14="http://schemas.microsoft.com/office/powerpoint/2010/main" val="2295079658"/>
-      </p:ext>
-    </p:extLst>
   </p:cSld>
   <p:clrMap bg1="lt1" tx1="dk1" bg2="lt2" tx2="dk2" accent1="accent1" accent2="accent2" accent3="accent3" accent4="accent4" accent5="accent5" accent6="accent6" hlink="hlink" folHlink="folHlink"/>
   <p:sldLayoutIdLst>
-    <p:sldLayoutId id="2147483661" r:id="rId1"/>
-    <p:sldLayoutId id="2147483662" r:id="rId2"/>
-    <p:sldLayoutId id="2147483663" r:id="rId3"/>
-    <p:sldLayoutId id="2147483664" r:id="rId4"/>
-    <p:sldLayoutId id="2147483665" r:id="rId5"/>
-    <p:sldLayoutId id="2147483666" r:id="rId6"/>
-    <p:sldLayoutId id="2147483667" r:id="rId7"/>
-    <p:sldLayoutId id="2147483668" r:id="rId8"/>
-    <p:sldLayoutId id="2147483669" r:id="rId9"/>
-    <p:sldLayoutId id="2147483670" r:id="rId10"/>
-    <p:sldLayoutId id="2147483671" r:id="rId11"/>
+    <p:sldLayoutId id="2147483649" r:id="rId1"/>
+    <p:sldLayoutId id="2147483650" r:id="rId2"/>
+    <p:sldLayoutId id="2147483651" r:id="rId3"/>
+    <p:sldLayoutId id="2147483652" r:id="rId4"/>
+    <p:sldLayoutId id="2147483653" r:id="rId5"/>
+    <p:sldLayoutId id="2147483654" r:id="rId6"/>
+    <p:sldLayoutId id="2147483655" r:id="rId7"/>
+    <p:sldLayoutId id="2147483656" r:id="rId8"/>
+    <p:sldLayoutId id="2147483657" r:id="rId9"/>
+    <p:sldLayoutId id="2147483658" r:id="rId10"/>
+    <p:sldLayoutId id="2147483659" r:id="rId11"/>
   </p:sldLayoutIdLst>
   <p:txStyles>
     <p:titleStyle>
@@ -16031,7 +15964,7 @@
           <a:cs typeface="+mn-cs"/>
         </a:defRPr>
       </a:lvl1pPr>
-      <a:lvl2pPr marL="265176" indent="-137160" algn="l" defTabSz="914400" rtl="0" eaLnBrk="1" latinLnBrk="0" hangingPunct="1">
+      <a:lvl2pPr marL="265430" indent="-137160" algn="l" defTabSz="914400" rtl="0" eaLnBrk="1" latinLnBrk="0" hangingPunct="1">
         <a:lnSpc>
           <a:spcPct val="90000"/>
         </a:lnSpc>
@@ -16055,7 +15988,7 @@
           <a:cs typeface="+mn-cs"/>
         </a:defRPr>
       </a:lvl2pPr>
-      <a:lvl3pPr marL="448056" indent="-137160" algn="l" defTabSz="914400" rtl="0" eaLnBrk="1" latinLnBrk="0" hangingPunct="1">
+      <a:lvl3pPr marL="448310" indent="-137160" algn="l" defTabSz="914400" rtl="0" eaLnBrk="1" latinLnBrk="0" hangingPunct="1">
         <a:lnSpc>
           <a:spcPct val="90000"/>
         </a:lnSpc>
@@ -16151,7 +16084,7 @@
           <a:cs typeface="+mn-cs"/>
         </a:defRPr>
       </a:lvl6pPr>
-      <a:lvl7pPr marL="1060704" indent="-137160" algn="l" defTabSz="914400" rtl="0" eaLnBrk="1" latinLnBrk="0" hangingPunct="1">
+      <a:lvl7pPr marL="1060450" indent="-137160" algn="l" defTabSz="914400" rtl="0" eaLnBrk="1" latinLnBrk="0" hangingPunct="1">
         <a:lnSpc>
           <a:spcPct val="90000"/>
         </a:lnSpc>
@@ -16175,7 +16108,7 @@
           <a:cs typeface="+mn-cs"/>
         </a:defRPr>
       </a:lvl7pPr>
-      <a:lvl8pPr marL="1216152" indent="-137160" algn="l" defTabSz="914400" rtl="0" eaLnBrk="1" latinLnBrk="0" hangingPunct="1">
+      <a:lvl8pPr marL="1216025" indent="-137160" algn="l" defTabSz="914400" rtl="0" eaLnBrk="1" latinLnBrk="0" hangingPunct="1">
         <a:lnSpc>
           <a:spcPct val="90000"/>
         </a:lnSpc>
@@ -16199,7 +16132,7 @@
           <a:cs typeface="+mn-cs"/>
         </a:defRPr>
       </a:lvl8pPr>
-      <a:lvl9pPr marL="1362456" indent="-137160" algn="l" defTabSz="914400" rtl="0" eaLnBrk="1" latinLnBrk="0" hangingPunct="1">
+      <a:lvl9pPr marL="1362710" indent="-137160" algn="l" defTabSz="914400" rtl="0" eaLnBrk="1" latinLnBrk="0" hangingPunct="1">
         <a:lnSpc>
           <a:spcPct val="90000"/>
         </a:lnSpc>
@@ -16359,6 +16292,7 @@
               <a:rPr lang="en-US" dirty="0"/>
               <a:t>State Transition Testing Technique</a:t>
             </a:r>
+            <a:endParaRPr lang="en-US" dirty="0"/>
           </a:p>
         </p:txBody>
       </p:sp>
@@ -16447,7 +16381,7 @@
           </p:nvPr>
         </p:nvPicPr>
         <p:blipFill>
-          <a:blip r:embed="rId2"/>
+          <a:blip r:embed="rId1"/>
           <a:stretch>
             <a:fillRect/>
           </a:stretch>
@@ -16541,12 +16475,14 @@
               <a:rPr lang="en-US" dirty="0" smtClean="0"/>
               <a:t>at least once under test. Note that the test cases that cover each event can be the same as those that cover each state. </a:t>
             </a:r>
+            <a:endParaRPr lang="en-US" dirty="0" smtClean="0"/>
           </a:p>
           <a:p>
             <a:r>
               <a:rPr lang="en-US" dirty="0" smtClean="0"/>
               <a:t>Again, this is a weak level of coverage.</a:t>
             </a:r>
+            <a:endParaRPr lang="en-US" dirty="0" smtClean="0"/>
           </a:p>
           <a:p>
             <a:pPr>
@@ -16565,7 +16501,7 @@
           <p:nvPr/>
         </p:nvPicPr>
         <p:blipFill>
-          <a:blip r:embed="rId2"/>
+          <a:blip r:embed="rId1"/>
           <a:stretch>
             <a:fillRect/>
           </a:stretch>
@@ -16659,7 +16595,7 @@
           <p:nvPr/>
         </p:nvPicPr>
         <p:blipFill>
-          <a:blip r:embed="rId2"/>
+          <a:blip r:embed="rId1"/>
           <a:stretch>
             <a:fillRect/>
           </a:stretch>
@@ -16675,11 +16611,6 @@
         </p:spPr>
       </p:pic>
     </p:spTree>
-    <p:extLst>
-      <p:ext uri="{BB962C8B-B14F-4D97-AF65-F5344CB8AC3E}">
-        <p14:creationId xmlns:p14="http://schemas.microsoft.com/office/powerpoint/2010/main" val="247113852"/>
-      </p:ext>
-    </p:extLst>
   </p:cSld>
   <p:clrMapOvr>
     <a:masterClrMapping/>
@@ -16767,6 +16698,7 @@
               <a:rPr lang="en-US" dirty="0" smtClean="0"/>
               <a:t>.</a:t>
             </a:r>
+            <a:endParaRPr lang="en-US" dirty="0" smtClean="0"/>
           </a:p>
           <a:p>
             <a:r>
@@ -16777,6 +16709,7 @@
               <a:rPr lang="en-US" dirty="0" smtClean="0"/>
               <a:t>feasible</a:t>
             </a:r>
+            <a:endParaRPr lang="en-US" dirty="0" smtClean="0"/>
           </a:p>
           <a:p>
             <a:r>
@@ -16787,36 +16720,42 @@
               <a:rPr lang="en-US" dirty="0" smtClean="0"/>
               <a:t>.</a:t>
             </a:r>
+            <a:endParaRPr lang="en-US" dirty="0" smtClean="0"/>
           </a:p>
           <a:p>
             <a:r>
               <a:rPr lang="en-US" dirty="0"/>
               <a:t>A→B</a:t>
             </a:r>
+            <a:endParaRPr lang="en-US" dirty="0"/>
           </a:p>
           <a:p>
             <a:r>
               <a:rPr lang="en-US" dirty="0"/>
               <a:t>A→B→A</a:t>
             </a:r>
+            <a:endParaRPr lang="en-US" dirty="0"/>
           </a:p>
           <a:p>
             <a:r>
               <a:rPr lang="en-US" dirty="0"/>
               <a:t>A→B→A→B→A→B</a:t>
             </a:r>
+            <a:endParaRPr lang="en-US" dirty="0"/>
           </a:p>
           <a:p>
             <a:r>
               <a:rPr lang="en-US" dirty="0"/>
               <a:t>A→B→A→B→A→B→A</a:t>
             </a:r>
+            <a:endParaRPr lang="en-US" dirty="0"/>
           </a:p>
           <a:p>
             <a:r>
               <a:rPr lang="en-US" dirty="0"/>
               <a:t>A→B→A→B→A→B→A→B→A→B</a:t>
             </a:r>
+            <a:endParaRPr lang="en-US" dirty="0"/>
           </a:p>
           <a:p>
             <a:endParaRPr lang="en-US" dirty="0"/>
@@ -16980,7 +16919,7 @@
           </p:nvPr>
         </p:nvPicPr>
         <p:blipFill>
-          <a:blip r:embed="rId2"/>
+          <a:blip r:embed="rId1"/>
           <a:stretch>
             <a:fillRect/>
           </a:stretch>
@@ -17053,10 +16992,6 @@
             <a:br>
               <a:rPr lang="en-US" dirty="0"/>
             </a:br>
-            <a:r>
-              <a:rPr lang="en-US" dirty="0"/>
-              <a:t/>
-            </a:r>
             <a:br>
               <a:rPr lang="en-US" dirty="0"/>
             </a:br>
@@ -17092,6 +17027,7 @@
               <a:rPr lang="en-US" dirty="0" smtClean="0"/>
               <a:t>transitions</a:t>
             </a:r>
+            <a:endParaRPr lang="en-US" dirty="0" smtClean="0"/>
           </a:p>
           <a:p>
             <a:endParaRPr lang="en-US" dirty="0"/>
@@ -17105,6 +17041,7 @@
               <a:rPr lang="en-US" dirty="0" smtClean="0"/>
               <a:t>.</a:t>
             </a:r>
+            <a:endParaRPr lang="en-US" dirty="0" smtClean="0"/>
           </a:p>
           <a:p>
             <a:endParaRPr lang="en-US" dirty="0"/>
@@ -17118,6 +17055,7 @@
               <a:rPr lang="en-US" dirty="0" smtClean="0"/>
               <a:t>system</a:t>
             </a:r>
+            <a:endParaRPr lang="en-US" dirty="0" smtClean="0"/>
           </a:p>
           <a:p>
             <a:pPr lvl="1"/>
@@ -17125,15 +17063,11 @@
               <a:rPr lang="en-US" dirty="0"/>
               <a:t>An example is a payroll program that reads an employee's time record, computes pay, subtracts deductions, saves the record, prints a paycheck, and repeats the process.</a:t>
             </a:r>
+            <a:endParaRPr lang="en-US" dirty="0"/>
           </a:p>
         </p:txBody>
       </p:sp>
     </p:spTree>
-    <p:extLst>
-      <p:ext uri="{BB962C8B-B14F-4D97-AF65-F5344CB8AC3E}">
-        <p14:creationId xmlns:p14="http://schemas.microsoft.com/office/powerpoint/2010/main" val="3168158309"/>
-      </p:ext>
-    </p:extLst>
   </p:cSld>
   <p:clrMapOvr>
     <a:masterClrMapping/>
@@ -17207,15 +17141,11 @@
               <a:rPr lang="en-US" dirty="0"/>
               <a:t>https://flylib.com/books/en/2.156.1/state_transition_testing.html</a:t>
             </a:r>
+            <a:endParaRPr lang="en-US" dirty="0"/>
           </a:p>
         </p:txBody>
       </p:sp>
     </p:spTree>
-    <p:extLst>
-      <p:ext uri="{BB962C8B-B14F-4D97-AF65-F5344CB8AC3E}">
-        <p14:creationId xmlns:p14="http://schemas.microsoft.com/office/powerpoint/2010/main" val="1983595340"/>
-      </p:ext>
-    </p:extLst>
   </p:cSld>
   <p:clrMapOvr>
     <a:masterClrMapping/>
@@ -17464,20 +17394,12 @@
               <a:rPr lang="en-US" dirty="0"/>
               <a:t>1.  understand State Transition diagrams and State tables</a:t>
             </a:r>
-            <a:r>
-              <a:rPr lang="en-US" dirty="0" smtClean="0"/>
-              <a:t/>
-            </a:r>
             <a:br>
               <a:rPr lang="en-US" dirty="0" smtClean="0"/>
             </a:br>
             <a:r>
               <a:rPr lang="en-US" dirty="0"/>
               <a:t>2.  derive test cases from the State Transition diagrams and State Tables</a:t>
-            </a:r>
-            <a:r>
-              <a:rPr lang="en-US" dirty="0" smtClean="0"/>
-              <a:t/>
             </a:r>
             <a:br>
               <a:rPr lang="en-US" dirty="0" smtClean="0"/>
@@ -17486,10 +17408,6 @@
               <a:rPr lang="en-US" dirty="0"/>
               <a:t>3.  Sequences – shortest, longest sequences</a:t>
             </a:r>
-            <a:r>
-              <a:rPr lang="en-US" dirty="0" smtClean="0"/>
-              <a:t/>
-            </a:r>
             <a:br>
               <a:rPr lang="en-US" dirty="0" smtClean="0"/>
             </a:br>
@@ -17497,6 +17415,7 @@
               <a:rPr lang="en-US" dirty="0"/>
               <a:t>4.  Null or Invalid transitions</a:t>
             </a:r>
+            <a:endParaRPr lang="en-US" dirty="0"/>
           </a:p>
         </p:txBody>
       </p:sp>
@@ -17578,6 +17497,7 @@
               <a:rPr lang="en-US" dirty="0"/>
               <a:t>of a system and are part of the Software Design Document.</a:t>
             </a:r>
+            <a:endParaRPr lang="en-US" dirty="0"/>
           </a:p>
         </p:txBody>
       </p:sp>
@@ -17625,8 +17545,8 @@
         </p:nvSpPr>
         <p:spPr>
           <a:xfrm>
-            <a:off x="762000" y="304800"/>
-            <a:ext cx="8153400" cy="6172200"/>
+            <a:off x="0" y="304800"/>
+            <a:ext cx="9083675" cy="6172200"/>
           </a:xfrm>
         </p:spPr>
         <p:txBody>
@@ -17636,88 +17556,86 @@
           <a:lstStyle/>
           <a:p>
             <a:r>
-              <a:rPr lang="en-US" sz="2400" dirty="0" smtClean="0"/>
+              <a:rPr lang="en-US" dirty="0" smtClean="0"/>
               <a:t>State </a:t>
             </a:r>
             <a:r>
-              <a:rPr lang="en-US" sz="2400" dirty="0"/>
+              <a:rPr lang="en-US" dirty="0"/>
               <a:t>(represented by a circle)—A state is a condition in which a system is waiting for one or more events. States "remember" inputs the system has received in the past and define how the system should respond to subsequent events when they occur. </a:t>
             </a:r>
-            <a:endParaRPr lang="en-US" sz="2400" dirty="0" smtClean="0"/>
+            <a:endParaRPr lang="en-US" dirty="0" smtClean="0"/>
           </a:p>
           <a:p>
             <a:r>
-              <a:rPr lang="en-US" sz="2400" dirty="0" smtClean="0"/>
+              <a:rPr lang="en-US" dirty="0" smtClean="0"/>
               <a:t>Transition </a:t>
             </a:r>
             <a:r>
-              <a:rPr lang="en-US" sz="2400" dirty="0"/>
+              <a:rPr lang="en-US" dirty="0"/>
               <a:t>(represented by an arrow)—A transition represents a change from one state to another caused by an event.</a:t>
             </a:r>
+            <a:endParaRPr lang="en-US" dirty="0"/>
           </a:p>
           <a:p>
             <a:r>
-              <a:rPr lang="en-US" sz="2400" dirty="0"/>
+              <a:rPr lang="en-US" dirty="0"/>
               <a:t>Event (represented by a label on a transition)—An event is something that causes the system to change state. Generally, it is an event in the outside world that enters the system through its interface. Sometimes it is generated within the system such as </a:t>
             </a:r>
             <a:r>
-              <a:rPr lang="en-US" sz="2400" b="1" dirty="0"/>
+              <a:rPr lang="en-US" b="1" dirty="0"/>
               <a:t>Timer expires</a:t>
             </a:r>
             <a:r>
-              <a:rPr lang="en-US" sz="2400" dirty="0"/>
+              <a:rPr lang="en-US" dirty="0"/>
               <a:t> or </a:t>
             </a:r>
             <a:r>
-              <a:rPr lang="en-US" sz="2400" b="1" dirty="0"/>
+              <a:rPr lang="en-US" b="1" dirty="0"/>
               <a:t>Quantity on Hand goes below Reorder Point.</a:t>
             </a:r>
             <a:r>
-              <a:rPr lang="en-US" sz="2400" dirty="0"/>
+              <a:rPr lang="en-US" dirty="0"/>
               <a:t> </a:t>
             </a:r>
+            <a:endParaRPr lang="en-US" dirty="0"/>
           </a:p>
           <a:p>
             <a:r>
-              <a:rPr lang="en-US" sz="2400" dirty="0"/>
+              <a:rPr lang="en-US" dirty="0"/>
               <a:t>Action (represented by a command following a "</a:t>
             </a:r>
             <a:r>
-              <a:rPr lang="en-US" sz="2400" b="1" dirty="0"/>
+              <a:rPr lang="en-US" b="1" dirty="0"/>
               <a:t>/</a:t>
             </a:r>
             <a:r>
-              <a:rPr lang="en-US" sz="2400" dirty="0"/>
+              <a:rPr lang="en-US" dirty="0"/>
               <a:t>")—An action is an operation initiated because of a state change. It could be </a:t>
             </a:r>
             <a:r>
-              <a:rPr lang="en-US" sz="2400" b="1" dirty="0"/>
+              <a:rPr lang="en-US" b="1" dirty="0"/>
               <a:t>print a Ticket, display a Screen, turn on a Motor,</a:t>
             </a:r>
             <a:r>
-              <a:rPr lang="en-US" sz="2400" dirty="0"/>
+              <a:rPr lang="en-US" dirty="0"/>
               <a:t> etc. Often these actions cause something to be created that are outputs of the system. Note that actions occur on transitions between states. The states themselves are passive.</a:t>
             </a:r>
+            <a:endParaRPr lang="en-US" dirty="0"/>
           </a:p>
           <a:p>
             <a:r>
-              <a:rPr lang="en-US" sz="2400" dirty="0"/>
+              <a:rPr lang="en-US" dirty="0"/>
               <a:t>The entry point on the diagram is shown by a black dot while the exit point is shown by a bulls-eye symbol</a:t>
             </a:r>
             <a:r>
-              <a:rPr lang="en-US" sz="2400" dirty="0" smtClean="0"/>
+              <a:rPr lang="en-US" dirty="0" smtClean="0"/>
               <a:t>.</a:t>
             </a:r>
-            <a:endParaRPr lang="en-US" sz="2400" dirty="0"/>
+            <a:endParaRPr lang="en-US" dirty="0" smtClean="0"/>
           </a:p>
         </p:txBody>
       </p:sp>
     </p:spTree>
-    <p:extLst>
-      <p:ext uri="{BB962C8B-B14F-4D97-AF65-F5344CB8AC3E}">
-        <p14:creationId xmlns:p14="http://schemas.microsoft.com/office/powerpoint/2010/main" val="1437093393"/>
-      </p:ext>
-    </p:extLst>
   </p:cSld>
   <p:clrMapOvr>
     <a:masterClrMapping/>
@@ -17783,7 +17701,7 @@
           </p:nvPr>
         </p:nvPicPr>
         <p:blipFill>
-          <a:blip r:embed="rId2"/>
+          <a:blip r:embed="rId1"/>
           <a:stretch>
             <a:fillRect/>
           </a:stretch>
@@ -17840,7 +17758,7 @@
         <p:spPr>
           <a:xfrm>
             <a:off x="685800" y="76200"/>
-            <a:ext cx="7290054" cy="1499616"/>
+            <a:ext cx="7289800" cy="795655"/>
           </a:xfrm>
         </p:spPr>
         <p:txBody>
@@ -17848,9 +17766,10 @@
           <a:lstStyle/>
           <a:p>
             <a:r>
-              <a:rPr lang="en-US" dirty="0"/>
+              <a:rPr lang="en-US" sz="3600" dirty="0"/>
               <a:t>State-transition table.</a:t>
             </a:r>
+            <a:endParaRPr lang="en-US" sz="3600" dirty="0"/>
           </a:p>
         </p:txBody>
       </p:sp>
@@ -17863,7 +17782,7 @@
           <p:nvPr/>
         </p:nvPicPr>
         <p:blipFill>
-          <a:blip r:embed="rId2"/>
+          <a:blip r:embed="rId1"/>
           <a:stretch>
             <a:fillRect/>
           </a:stretch>
@@ -17887,7 +17806,7 @@
           <p:nvPr/>
         </p:nvPicPr>
         <p:blipFill>
-          <a:blip r:embed="rId3"/>
+          <a:blip r:embed="rId2"/>
           <a:stretch>
             <a:fillRect/>
           </a:stretch>
@@ -17953,6 +17872,7 @@
               <a:rPr lang="en-US" dirty="0"/>
               <a:t>State-transition table.</a:t>
             </a:r>
+            <a:endParaRPr lang="en-US" dirty="0"/>
           </a:p>
         </p:txBody>
       </p:sp>
@@ -17981,6 +17901,7 @@
               <a:rPr lang="en-US" dirty="0" smtClean="0"/>
               <a:t>.</a:t>
             </a:r>
+            <a:endParaRPr lang="en-US" dirty="0" smtClean="0"/>
           </a:p>
           <a:p>
             <a:r>
@@ -17991,21 +17912,18 @@
               <a:rPr lang="en-US" dirty="0" smtClean="0"/>
               <a:t>.</a:t>
             </a:r>
+            <a:endParaRPr lang="en-US" dirty="0" smtClean="0"/>
           </a:p>
           <a:p>
             <a:r>
               <a:rPr lang="en-US" dirty="0"/>
               <a:t>In addition, the tables are generally sparse; that is, most of the cells are empty.</a:t>
             </a:r>
+            <a:endParaRPr lang="en-US" dirty="0"/>
           </a:p>
         </p:txBody>
       </p:sp>
     </p:spTree>
-    <p:extLst>
-      <p:ext uri="{BB962C8B-B14F-4D97-AF65-F5344CB8AC3E}">
-        <p14:creationId xmlns:p14="http://schemas.microsoft.com/office/powerpoint/2010/main" val="3151272346"/>
-      </p:ext>
-    </p:extLst>
   </p:cSld>
   <p:clrMapOvr>
     <a:masterClrMapping/>
@@ -18081,6 +17999,7 @@
               <a:rPr lang="en-US" dirty="0" smtClean="0"/>
               <a:t>Information in the state-transition diagrams can easily be used to create test cases. Four different levels of coverage can be defined:</a:t>
             </a:r>
+            <a:endParaRPr lang="en-US" dirty="0" smtClean="0"/>
           </a:p>
           <a:p>
             <a:r>
@@ -18095,6 +18014,7 @@
               <a:rPr lang="en-US" dirty="0" smtClean="0"/>
               <a:t>least once under test.</a:t>
             </a:r>
+            <a:endParaRPr lang="en-US" dirty="0" smtClean="0"/>
           </a:p>
           <a:p>
             <a:r>
@@ -18106,11 +18026,6 @@
         </p:txBody>
       </p:sp>
     </p:spTree>
-    <p:extLst>
-      <p:ext uri="{BB962C8B-B14F-4D97-AF65-F5344CB8AC3E}">
-        <p14:creationId xmlns:p14="http://schemas.microsoft.com/office/powerpoint/2010/main" val="3189046724"/>
-      </p:ext>
-    </p:extLst>
   </p:cSld>
   <p:clrMapOvr>
     <a:masterClrMapping/>
@@ -18168,7 +18083,7 @@
     </a:clrScheme>
     <a:fontScheme name="Integral">
       <a:majorFont>
-        <a:latin typeface="Tw Cen MT Condensed" panose="020B0606020104020203"/>
+        <a:latin typeface="Tw Cen MT Condensed"/>
         <a:ea typeface=""/>
         <a:cs typeface=""/>
         <a:font script="Grek" typeface="Calibri"/>
@@ -18205,7 +18120,7 @@
         <a:font script="Geor" typeface="Sylfaen"/>
       </a:majorFont>
       <a:minorFont>
-        <a:latin typeface="Tw Cen MT" panose="020B0602020104020603"/>
+        <a:latin typeface="Tw Cen MT"/>
         <a:ea typeface=""/>
         <a:cs typeface=""/>
         <a:font script="Grek" typeface="Calibri"/>
@@ -18383,11 +18298,9 @@
       </a:bgFillStyleLst>
     </a:fmtScheme>
   </a:themeElements>
-  <a:objectDefaults/>
-  <a:extraClrSchemeLst/>
   <a:extLst>
     <a:ext uri="{05A4C25C-085E-4340-85A3-A5531E510DB2}">
-      <thm15:themeFamily xmlns:thm15="http://schemas.microsoft.com/office/thememl/2012/main" name="Integral" id="{3577F8C9-A904-41D8-97D2-FD898F53F20E}" vid="{682D6EBE-8D36-4FF2-9DB3-F3D8D7B6715D}"/>
+      <thm15:themeFamily xmlns:thm15="http://schemas.microsoft.com/office/thememl/2012/main" name="Office Theme" id="{62F939B6-93AF-4DB8-9C6B-D6C7DFDC589F}" vid="{4A3C46E8-61CC-4603-A589-7422A47A8E4A}"/>
     </a:ext>
   </a:extLst>
 </a:theme>

</xml_diff>